<commit_message>
Complete metadata cleaning and publish verified notebook results
</commit_message>
<xml_diff>
--- a/docs/presentation.pptx
+++ b/docs/presentation.pptx
@@ -18,6 +18,7 @@
     <p:sldId id="266" r:id="rId18"/>
     <p:sldId id="267" r:id="rId19"/>
     <p:sldId id="268" r:id="rId20"/>
+    <p:sldId id="269" r:id="rId21"/>
   </p:sldIdLst>
   <p:sldSz cx="12191695" cy="6858000" type="screen4x3"/>
   <p:notesSz cx="6858000" cy="9144000"/>
@@ -738,6 +739,72 @@
 </file>
 
 <file path=ppt/notesSlides/notesSlide13.xml><?xml version="1.0" encoding="utf-8"?>
+<p:notes xmlns:a="http://schemas.openxmlformats.org/drawingml/2006/main" xmlns:p="http://schemas.openxmlformats.org/presentationml/2006/main" xmlns:r="http://schemas.openxmlformats.org/officeDocument/2006/relationships">
+  <p:cSld>
+    <p:spTree>
+      <p:nvGrpSpPr>
+        <p:cNvPr id="1" name=""/>
+        <p:cNvGrpSpPr/>
+        <p:nvPr/>
+      </p:nvGrpSpPr>
+      <p:grpSpPr>
+        <a:xfrm>
+          <a:off x="0" y="0"/>
+          <a:ext cx="0" cy="0"/>
+          <a:chOff x="0" y="0"/>
+          <a:chExt cx="0" cy="0"/>
+        </a:xfrm>
+      </p:grpSpPr>
+      <p:sp>
+        <p:nvSpPr>
+          <p:cNvPr id="2" name="Slide Image Placeholder 1"/>
+          <p:cNvSpPr>
+            <a:spLocks noGrp="1"/>
+          </p:cNvSpPr>
+          <p:nvPr>
+            <p:ph type="sldImg" idx="2"/>
+          </p:nvPr>
+        </p:nvSpPr>
+        <p:spPr/>
+      </p:sp>
+      <p:sp>
+        <p:nvSpPr>
+          <p:cNvPr id="3" name="Notes Placeholder 2"/>
+          <p:cNvSpPr>
+            <a:spLocks noGrp="1"/>
+          </p:cNvSpPr>
+          <p:nvPr>
+            <p:ph type="body" idx="3" sz="quarter"/>
+          </p:nvPr>
+        </p:nvSpPr>
+        <p:spPr/>
+        <p:txBody>
+          <a:bodyPr/>
+          <a:lstStyle/>
+          <a:p/>
+        </p:txBody>
+      </p:sp>
+      <p:sp>
+        <p:nvSpPr>
+          <p:cNvPr id="4" name="Slide Number Placeholder 3"/>
+          <p:cNvSpPr>
+            <a:spLocks noGrp="1"/>
+          </p:cNvSpPr>
+          <p:nvPr>
+            <p:ph type="sldNum" idx="5" sz="quarter"/>
+          </p:nvPr>
+        </p:nvSpPr>
+        <p:spPr/>
+      </p:sp>
+    </p:spTree>
+  </p:cSld>
+  <p:clrMapOvr>
+    <a:masterClrMapping/>
+  </p:clrMapOvr>
+</p:notes>
+</file>
+
+<file path=ppt/notesSlides/notesSlide14.xml><?xml version="1.0" encoding="utf-8"?>
 <p:notes xmlns:a="http://schemas.openxmlformats.org/drawingml/2006/main" xmlns:p="http://schemas.openxmlformats.org/presentationml/2006/main" xmlns:r="http://schemas.openxmlformats.org/officeDocument/2006/relationships">
   <p:cSld>
     <p:spTree>
@@ -7397,6 +7464,725 @@
             </a:pPr>
             <a:r>
               <a:t>Separate 128-case synthetic holdout: 50.0% base → 75.0% tuned; real accuracy unknown.</a:t>
+            </a:r>
+          </a:p>
+        </p:txBody>
+      </p:sp>
+    </p:spTree>
+  </p:cSld>
+  <p:clrMapOvr>
+    <a:masterClrMapping/>
+  </p:clrMapOvr>
+</p:sld>
+</file>
+
+<file path=ppt/slides/slide14.xml><?xml version="1.0" encoding="utf-8"?>
+<p:sld xmlns:a="http://schemas.openxmlformats.org/drawingml/2006/main" xmlns:p="http://schemas.openxmlformats.org/presentationml/2006/main" xmlns:r="http://schemas.openxmlformats.org/officeDocument/2006/relationships">
+  <p:cSld>
+    <p:bg>
+      <p:bgPr>
+        <a:solidFill>
+          <a:srgbClr val="FFFFFF"/>
+        </a:solidFill>
+        <a:effectLst/>
+      </p:bgPr>
+    </p:bg>
+    <p:spTree>
+      <p:nvGrpSpPr>
+        <p:cNvPr id="1" name=""/>
+        <p:cNvGrpSpPr/>
+        <p:nvPr/>
+      </p:nvGrpSpPr>
+      <p:grpSpPr/>
+      <p:sp>
+        <p:nvSpPr>
+          <p:cNvPr id="2" name="TextBox 1"/>
+          <p:cNvSpPr txBox="1"/>
+          <p:nvPr/>
+        </p:nvSpPr>
+        <p:spPr>
+          <a:xfrm>
+            <a:off x="548640" y="228600"/>
+            <a:ext cx="10972800" cy="320040"/>
+          </a:xfrm>
+          <a:prstGeom prst="rect">
+            <a:avLst/>
+          </a:prstGeom>
+          <a:noFill/>
+        </p:spPr>
+        <p:txBody>
+          <a:bodyPr wrap="square">
+            <a:spAutoFit/>
+          </a:bodyPr>
+          <a:lstStyle/>
+          <a:p>
+            <a:pPr>
+              <a:spcAft>
+                <a:spcPts val="1200"/>
+              </a:spcAft>
+              <a:defRPr sz="1100" b="1">
+                <a:solidFill>
+                  <a:srgbClr val="007D80"/>
+                </a:solidFill>
+                <a:latin typeface="Aptos"/>
+              </a:defRPr>
+            </a:pPr>
+            <a:r>
+              <a:t>FRAUD SENTINEL  /  AI ENGINEERING HACKATHON</a:t>
+            </a:r>
+          </a:p>
+        </p:txBody>
+      </p:sp>
+      <p:sp>
+        <p:nvSpPr>
+          <p:cNvPr id="3" name="TextBox 2"/>
+          <p:cNvSpPr txBox="1"/>
+          <p:nvPr/>
+        </p:nvSpPr>
+        <p:spPr>
+          <a:xfrm>
+            <a:off x="548640" y="868680"/>
+            <a:ext cx="10972800" cy="914400"/>
+          </a:xfrm>
+          <a:prstGeom prst="rect">
+            <a:avLst/>
+          </a:prstGeom>
+          <a:noFill/>
+        </p:spPr>
+        <p:txBody>
+          <a:bodyPr wrap="square">
+            <a:spAutoFit/>
+          </a:bodyPr>
+          <a:lstStyle/>
+          <a:p>
+            <a:pPr>
+              <a:spcAft>
+                <a:spcPts val="1200"/>
+              </a:spcAft>
+              <a:defRPr sz="3400" b="1">
+                <a:solidFill>
+                  <a:srgbClr val="101D35"/>
+                </a:solidFill>
+                <a:latin typeface="Aptos"/>
+              </a:defRPr>
+            </a:pPr>
+            <a:r>
+              <a:t>Metadata cleaning: the baseline gap is closed</a:t>
+            </a:r>
+          </a:p>
+        </p:txBody>
+      </p:sp>
+      <p:sp>
+        <p:nvSpPr>
+          <p:cNvPr id="4" name="TextBox 3"/>
+          <p:cNvSpPr txBox="1"/>
+          <p:nvPr/>
+        </p:nvSpPr>
+        <p:spPr>
+          <a:xfrm>
+            <a:off x="548640" y="1783080"/>
+            <a:ext cx="10972800" cy="731520"/>
+          </a:xfrm>
+          <a:prstGeom prst="rect">
+            <a:avLst/>
+          </a:prstGeom>
+          <a:noFill/>
+        </p:spPr>
+        <p:txBody>
+          <a:bodyPr wrap="square">
+            <a:spAutoFit/>
+          </a:bodyPr>
+          <a:lstStyle/>
+          <a:p>
+            <a:pPr>
+              <a:spcAft>
+                <a:spcPts val="1200"/>
+              </a:spcAft>
+              <a:defRPr sz="1800" b="0">
+                <a:solidFill>
+                  <a:srgbClr val="596B82"/>
+                </a:solidFill>
+                <a:latin typeface="Aptos"/>
+              </a:defRPr>
+            </a:pPr>
+            <a:r>
+              <a:t>Typed account/customer tables are cleaned, linked, and exported locally.</a:t>
+            </a:r>
+          </a:p>
+        </p:txBody>
+      </p:sp>
+      <p:sp>
+        <p:nvSpPr>
+          <p:cNvPr id="5" name="TextBox 4"/>
+          <p:cNvSpPr txBox="1"/>
+          <p:nvPr/>
+        </p:nvSpPr>
+        <p:spPr>
+          <a:xfrm>
+            <a:off x="548640" y="6428232"/>
+            <a:ext cx="10058400" cy="274320"/>
+          </a:xfrm>
+          <a:prstGeom prst="rect">
+            <a:avLst/>
+          </a:prstGeom>
+          <a:noFill/>
+        </p:spPr>
+        <p:txBody>
+          <a:bodyPr wrap="square">
+            <a:spAutoFit/>
+          </a:bodyPr>
+          <a:lstStyle/>
+          <a:p>
+            <a:pPr>
+              <a:spcAft>
+                <a:spcPts val="1200"/>
+              </a:spcAft>
+              <a:defRPr sz="1000" b="0">
+                <a:solidFill>
+                  <a:srgbClr val="596B82"/>
+                </a:solidFill>
+                <a:latin typeface="Aptos"/>
+              </a:defRPr>
+            </a:pPr>
+            <a:r>
+              <a:t>RELATIONAL DATA → SMALL MODEL → STRICT JSON</a:t>
+            </a:r>
+          </a:p>
+        </p:txBody>
+      </p:sp>
+      <p:sp>
+        <p:nvSpPr>
+          <p:cNvPr id="6" name="TextBox 5"/>
+          <p:cNvSpPr txBox="1"/>
+          <p:nvPr/>
+        </p:nvSpPr>
+        <p:spPr>
+          <a:xfrm>
+            <a:off x="11018520" y="6400800"/>
+            <a:ext cx="548640" cy="320040"/>
+          </a:xfrm>
+          <a:prstGeom prst="rect">
+            <a:avLst/>
+          </a:prstGeom>
+          <a:noFill/>
+        </p:spPr>
+        <p:txBody>
+          <a:bodyPr wrap="square">
+            <a:spAutoFit/>
+          </a:bodyPr>
+          <a:lstStyle/>
+          <a:p>
+            <a:pPr>
+              <a:spcAft>
+                <a:spcPts val="1200"/>
+              </a:spcAft>
+              <a:defRPr sz="1200" b="0">
+                <a:solidFill>
+                  <a:srgbClr val="007D80"/>
+                </a:solidFill>
+                <a:latin typeface="Aptos"/>
+              </a:defRPr>
+            </a:pPr>
+            <a:r>
+              <a:t>14</a:t>
+            </a:r>
+          </a:p>
+        </p:txBody>
+      </p:sp>
+      <p:sp>
+        <p:nvSpPr>
+          <p:cNvPr id="7" name="Rounded Rectangle 6"/>
+          <p:cNvSpPr/>
+          <p:nvPr/>
+        </p:nvSpPr>
+        <p:spPr>
+          <a:xfrm>
+            <a:off x="640080" y="2743200"/>
+            <a:ext cx="3383280" cy="2560320"/>
+          </a:xfrm>
+          <a:prstGeom prst="roundRect">
+            <a:avLst/>
+          </a:prstGeom>
+          <a:solidFill>
+            <a:srgbClr val="E9F4F4"/>
+          </a:solidFill>
+          <a:ln>
+            <a:noFill/>
+          </a:ln>
+        </p:spPr>
+        <p:style>
+          <a:lnRef idx="1">
+            <a:schemeClr val="accent1"/>
+          </a:lnRef>
+          <a:fillRef idx="3">
+            <a:schemeClr val="accent1"/>
+          </a:fillRef>
+          <a:effectRef idx="2">
+            <a:schemeClr val="accent1"/>
+          </a:effectRef>
+          <a:fontRef idx="minor">
+            <a:schemeClr val="lt1"/>
+          </a:fontRef>
+        </p:style>
+        <p:txBody>
+          <a:bodyPr rtlCol="0" anchor="ctr"/>
+          <a:lstStyle/>
+          <a:p>
+            <a:pPr algn="ctr"/>
+          </a:p>
+        </p:txBody>
+      </p:sp>
+      <p:sp>
+        <p:nvSpPr>
+          <p:cNvPr id="8" name="TextBox 7"/>
+          <p:cNvSpPr txBox="1"/>
+          <p:nvPr/>
+        </p:nvSpPr>
+        <p:spPr>
+          <a:xfrm>
+            <a:off x="822959" y="2926080"/>
+            <a:ext cx="3017520" cy="548640"/>
+          </a:xfrm>
+          <a:prstGeom prst="rect">
+            <a:avLst/>
+          </a:prstGeom>
+          <a:noFill/>
+        </p:spPr>
+        <p:txBody>
+          <a:bodyPr wrap="square">
+            <a:spAutoFit/>
+          </a:bodyPr>
+          <a:lstStyle/>
+          <a:p>
+            <a:pPr>
+              <a:spcAft>
+                <a:spcPts val="1200"/>
+              </a:spcAft>
+              <a:defRPr sz="2300" b="1">
+                <a:solidFill>
+                  <a:srgbClr val="007D80"/>
+                </a:solidFill>
+                <a:latin typeface="Aptos"/>
+              </a:defRPr>
+            </a:pPr>
+            <a:r>
+              <a:t>CLEAN</a:t>
+            </a:r>
+          </a:p>
+        </p:txBody>
+      </p:sp>
+      <p:sp>
+        <p:nvSpPr>
+          <p:cNvPr id="9" name="TextBox 8"/>
+          <p:cNvSpPr txBox="1"/>
+          <p:nvPr/>
+        </p:nvSpPr>
+        <p:spPr>
+          <a:xfrm>
+            <a:off x="822959" y="3611880"/>
+            <a:ext cx="3017520" cy="1645919"/>
+          </a:xfrm>
+          <a:prstGeom prst="rect">
+            <a:avLst/>
+          </a:prstGeom>
+          <a:noFill/>
+        </p:spPr>
+        <p:txBody>
+          <a:bodyPr wrap="square">
+            <a:spAutoFit/>
+          </a:bodyPr>
+          <a:lstStyle/>
+          <a:p>
+            <a:pPr>
+              <a:spcAft>
+                <a:spcPts val="1200"/>
+              </a:spcAft>
+              <a:defRPr sz="2000" b="0">
+                <a:solidFill>
+                  <a:srgbClr val="20324B"/>
+                </a:solidFill>
+                <a:latin typeface="Aptos"/>
+              </a:defRPr>
+            </a:pPr>
+            <a:r>
+              <a:t>21 account columns</a:t>
+            </a:r>
+          </a:p>
+          <a:p>
+            <a:pPr>
+              <a:spcAft>
+                <a:spcPts val="1200"/>
+              </a:spcAft>
+              <a:defRPr sz="2000" b="0">
+                <a:solidFill>
+                  <a:srgbClr val="20324B"/>
+                </a:solidFill>
+                <a:latin typeface="Aptos"/>
+              </a:defRPr>
+            </a:pPr>
+            <a:r>
+              <a:t>26 customer columns</a:t>
+            </a:r>
+          </a:p>
+          <a:p>
+            <a:pPr>
+              <a:spcAft>
+                <a:spcPts val="1200"/>
+              </a:spcAft>
+              <a:defRPr sz="2000" b="0">
+                <a:solidFill>
+                  <a:srgbClr val="20324B"/>
+                </a:solidFill>
+                <a:latin typeface="Aptos"/>
+              </a:defRPr>
+            </a:pPr>
+            <a:r>
+              <a:t>Typed values + issue flags</a:t>
+            </a:r>
+          </a:p>
+        </p:txBody>
+      </p:sp>
+      <p:sp>
+        <p:nvSpPr>
+          <p:cNvPr id="10" name="Rounded Rectangle 9"/>
+          <p:cNvSpPr/>
+          <p:nvPr/>
+        </p:nvSpPr>
+        <p:spPr>
+          <a:xfrm>
+            <a:off x="4389120" y="2743200"/>
+            <a:ext cx="3383280" cy="2560320"/>
+          </a:xfrm>
+          <a:prstGeom prst="roundRect">
+            <a:avLst/>
+          </a:prstGeom>
+          <a:solidFill>
+            <a:srgbClr val="E9F4F4"/>
+          </a:solidFill>
+          <a:ln>
+            <a:noFill/>
+          </a:ln>
+        </p:spPr>
+        <p:style>
+          <a:lnRef idx="1">
+            <a:schemeClr val="accent1"/>
+          </a:lnRef>
+          <a:fillRef idx="3">
+            <a:schemeClr val="accent1"/>
+          </a:fillRef>
+          <a:effectRef idx="2">
+            <a:schemeClr val="accent1"/>
+          </a:effectRef>
+          <a:fontRef idx="minor">
+            <a:schemeClr val="lt1"/>
+          </a:fontRef>
+        </p:style>
+        <p:txBody>
+          <a:bodyPr rtlCol="0" anchor="ctr"/>
+          <a:lstStyle/>
+          <a:p>
+            <a:pPr algn="ctr"/>
+          </a:p>
+        </p:txBody>
+      </p:sp>
+      <p:sp>
+        <p:nvSpPr>
+          <p:cNvPr id="11" name="TextBox 10"/>
+          <p:cNvSpPr txBox="1"/>
+          <p:nvPr/>
+        </p:nvSpPr>
+        <p:spPr>
+          <a:xfrm>
+            <a:off x="4572000" y="2926080"/>
+            <a:ext cx="3017520" cy="548640"/>
+          </a:xfrm>
+          <a:prstGeom prst="rect">
+            <a:avLst/>
+          </a:prstGeom>
+          <a:noFill/>
+        </p:spPr>
+        <p:txBody>
+          <a:bodyPr wrap="square">
+            <a:spAutoFit/>
+          </a:bodyPr>
+          <a:lstStyle/>
+          <a:p>
+            <a:pPr>
+              <a:spcAft>
+                <a:spcPts val="1200"/>
+              </a:spcAft>
+              <a:defRPr sz="2300" b="1">
+                <a:solidFill>
+                  <a:srgbClr val="007D80"/>
+                </a:solidFill>
+                <a:latin typeface="Aptos"/>
+              </a:defRPr>
+            </a:pPr>
+            <a:r>
+              <a:t>PRESERVE</a:t>
+            </a:r>
+          </a:p>
+        </p:txBody>
+      </p:sp>
+      <p:sp>
+        <p:nvSpPr>
+          <p:cNvPr id="12" name="TextBox 11"/>
+          <p:cNvSpPr txBox="1"/>
+          <p:nvPr/>
+        </p:nvSpPr>
+        <p:spPr>
+          <a:xfrm>
+            <a:off x="4572000" y="3611880"/>
+            <a:ext cx="3017520" cy="1645919"/>
+          </a:xfrm>
+          <a:prstGeom prst="rect">
+            <a:avLst/>
+          </a:prstGeom>
+          <a:noFill/>
+        </p:spPr>
+        <p:txBody>
+          <a:bodyPr wrap="square">
+            <a:spAutoFit/>
+          </a:bodyPr>
+          <a:lstStyle/>
+          <a:p>
+            <a:pPr>
+              <a:spcAft>
+                <a:spcPts val="1200"/>
+              </a:spcAft>
+              <a:defRPr sz="2000" b="0">
+                <a:solidFill>
+                  <a:srgbClr val="20324B"/>
+                </a:solidFill>
+                <a:latin typeface="Aptos"/>
+              </a:defRPr>
+            </a:pPr>
+            <a:r>
+              <a:t>Zero limits and signed balances</a:t>
+            </a:r>
+          </a:p>
+          <a:p>
+            <a:pPr>
+              <a:spcAft>
+                <a:spcPts val="1200"/>
+              </a:spcAft>
+              <a:defRPr sz="2000" b="0">
+                <a:solidFill>
+                  <a:srgbClr val="20324B"/>
+                </a:solidFill>
+                <a:latin typeface="Aptos"/>
+              </a:defRPr>
+            </a:pPr>
+            <a:r>
+              <a:t>Original source rows</a:t>
+            </a:r>
+          </a:p>
+          <a:p>
+            <a:pPr>
+              <a:spcAft>
+                <a:spcPts val="1200"/>
+              </a:spcAft>
+              <a:defRPr sz="2000" b="0">
+                <a:solidFill>
+                  <a:srgbClr val="20324B"/>
+                </a:solidFill>
+                <a:latin typeface="Aptos"/>
+              </a:defRPr>
+            </a:pPr>
+            <a:r>
+              <a:t>Conflicts and missing values</a:t>
+            </a:r>
+          </a:p>
+        </p:txBody>
+      </p:sp>
+      <p:sp>
+        <p:nvSpPr>
+          <p:cNvPr id="13" name="Rounded Rectangle 12"/>
+          <p:cNvSpPr/>
+          <p:nvPr/>
+        </p:nvSpPr>
+        <p:spPr>
+          <a:xfrm>
+            <a:off x="8138160" y="2743200"/>
+            <a:ext cx="3383280" cy="2560320"/>
+          </a:xfrm>
+          <a:prstGeom prst="roundRect">
+            <a:avLst/>
+          </a:prstGeom>
+          <a:solidFill>
+            <a:srgbClr val="E9F4F4"/>
+          </a:solidFill>
+          <a:ln>
+            <a:noFill/>
+          </a:ln>
+        </p:spPr>
+        <p:style>
+          <a:lnRef idx="1">
+            <a:schemeClr val="accent1"/>
+          </a:lnRef>
+          <a:fillRef idx="3">
+            <a:schemeClr val="accent1"/>
+          </a:fillRef>
+          <a:effectRef idx="2">
+            <a:schemeClr val="accent1"/>
+          </a:effectRef>
+          <a:fontRef idx="minor">
+            <a:schemeClr val="lt1"/>
+          </a:fontRef>
+        </p:style>
+        <p:txBody>
+          <a:bodyPr rtlCol="0" anchor="ctr"/>
+          <a:lstStyle/>
+          <a:p>
+            <a:pPr algn="ctr"/>
+          </a:p>
+        </p:txBody>
+      </p:sp>
+      <p:sp>
+        <p:nvSpPr>
+          <p:cNvPr id="14" name="TextBox 13"/>
+          <p:cNvSpPr txBox="1"/>
+          <p:nvPr/>
+        </p:nvSpPr>
+        <p:spPr>
+          <a:xfrm>
+            <a:off x="8321040" y="2926080"/>
+            <a:ext cx="3017520" cy="548640"/>
+          </a:xfrm>
+          <a:prstGeom prst="rect">
+            <a:avLst/>
+          </a:prstGeom>
+          <a:noFill/>
+        </p:spPr>
+        <p:txBody>
+          <a:bodyPr wrap="square">
+            <a:spAutoFit/>
+          </a:bodyPr>
+          <a:lstStyle/>
+          <a:p>
+            <a:pPr>
+              <a:spcAft>
+                <a:spcPts val="1200"/>
+              </a:spcAft>
+              <a:defRPr sz="2300" b="1">
+                <a:solidFill>
+                  <a:srgbClr val="007D80"/>
+                </a:solidFill>
+                <a:latin typeface="Aptos"/>
+              </a:defRPr>
+            </a:pPr>
+            <a:r>
+              <a:t>VERIFY</a:t>
+            </a:r>
+          </a:p>
+        </p:txBody>
+      </p:sp>
+      <p:sp>
+        <p:nvSpPr>
+          <p:cNvPr id="15" name="TextBox 14"/>
+          <p:cNvSpPr txBox="1"/>
+          <p:nvPr/>
+        </p:nvSpPr>
+        <p:spPr>
+          <a:xfrm>
+            <a:off x="8321040" y="3611880"/>
+            <a:ext cx="3017520" cy="1645919"/>
+          </a:xfrm>
+          <a:prstGeom prst="rect">
+            <a:avLst/>
+          </a:prstGeom>
+          <a:noFill/>
+        </p:spPr>
+        <p:txBody>
+          <a:bodyPr wrap="square">
+            <a:spAutoFit/>
+          </a:bodyPr>
+          <a:lstStyle/>
+          <a:p>
+            <a:pPr>
+              <a:spcAft>
+                <a:spcPts val="1200"/>
+              </a:spcAft>
+              <a:defRPr sz="2000" b="0">
+                <a:solidFill>
+                  <a:srgbClr val="20324B"/>
+                </a:solidFill>
+                <a:latin typeface="Aptos"/>
+              </a:defRPr>
+            </a:pPr>
+            <a:r>
+              <a:t>178 accounts retained</a:t>
+            </a:r>
+          </a:p>
+          <a:p>
+            <a:pPr>
+              <a:spcAft>
+                <a:spcPts val="1200"/>
+              </a:spcAft>
+              <a:defRPr sz="2000" b="0">
+                <a:solidFill>
+                  <a:srgbClr val="20324B"/>
+                </a:solidFill>
+                <a:latin typeface="Aptos"/>
+              </a:defRPr>
+            </a:pPr>
+            <a:r>
+              <a:t>124 customers retained</a:t>
+            </a:r>
+          </a:p>
+          <a:p>
+            <a:pPr>
+              <a:spcAft>
+                <a:spcPts val="1200"/>
+              </a:spcAft>
+              <a:defRPr sz="2000" b="0">
+                <a:solidFill>
+                  <a:srgbClr val="20324B"/>
+                </a:solidFill>
+                <a:latin typeface="Aptos"/>
+              </a:defRPr>
+            </a:pPr>
+            <a:r>
+              <a:t>Corrupt-metadata fixtures pass</a:t>
+            </a:r>
+          </a:p>
+        </p:txBody>
+      </p:sp>
+      <p:sp>
+        <p:nvSpPr>
+          <p:cNvPr id="16" name="TextBox 15"/>
+          <p:cNvSpPr txBox="1"/>
+          <p:nvPr/>
+        </p:nvSpPr>
+        <p:spPr>
+          <a:xfrm>
+            <a:off x="731520" y="5623560"/>
+            <a:ext cx="10789920" cy="548640"/>
+          </a:xfrm>
+          <a:prstGeom prst="rect">
+            <a:avLst/>
+          </a:prstGeom>
+          <a:noFill/>
+        </p:spPr>
+        <p:txBody>
+          <a:bodyPr wrap="square">
+            <a:spAutoFit/>
+          </a:bodyPr>
+          <a:lstStyle/>
+          <a:p>
+            <a:pPr>
+              <a:spcAft>
+                <a:spcPts val="1200"/>
+              </a:spcAft>
+              <a:defRPr sz="1900" b="0">
+                <a:solidFill>
+                  <a:srgbClr val="596B82"/>
+                </a:solidFill>
+                <a:latin typeface="Aptos"/>
+              </a:defRPr>
+            </a:pPr>
+            <a:r>
+              <a:t>Cleaned personal metadata stays local; model prompts retain the typed feature allowlist.</a:t>
             </a:r>
           </a:p>
         </p:txBody>

</xml_diff>

<commit_message>
Publish trained Llama adapter, dummy data, results and checkpoint deck
</commit_message>
<xml_diff>
--- a/docs/presentation.pptx
+++ b/docs/presentation.pptx
@@ -19,6 +19,7 @@
     <p:sldId id="267" r:id="rId19"/>
     <p:sldId id="268" r:id="rId20"/>
     <p:sldId id="269" r:id="rId21"/>
+    <p:sldId id="270" r:id="rId22"/>
   </p:sldIdLst>
   <p:sldSz cx="12191695" cy="6858000" type="screen4x3"/>
   <p:notesSz cx="6858000" cy="9144000"/>
@@ -848,6 +849,76 @@
           <a:bodyPr/>
           <a:lstStyle/>
           <a:p/>
+        </p:txBody>
+      </p:sp>
+      <p:sp>
+        <p:nvSpPr>
+          <p:cNvPr id="4" name="Slide Number Placeholder 3"/>
+          <p:cNvSpPr>
+            <a:spLocks noGrp="1"/>
+          </p:cNvSpPr>
+          <p:nvPr>
+            <p:ph type="sldNum" idx="5" sz="quarter"/>
+          </p:nvPr>
+        </p:nvSpPr>
+        <p:spPr/>
+      </p:sp>
+    </p:spTree>
+  </p:cSld>
+  <p:clrMapOvr>
+    <a:masterClrMapping/>
+  </p:clrMapOvr>
+</p:notes>
+</file>
+
+<file path=ppt/notesSlides/notesSlide15.xml><?xml version="1.0" encoding="utf-8"?>
+<p:notes xmlns:a="http://schemas.openxmlformats.org/drawingml/2006/main" xmlns:p="http://schemas.openxmlformats.org/presentationml/2006/main" xmlns:r="http://schemas.openxmlformats.org/officeDocument/2006/relationships">
+  <p:cSld>
+    <p:spTree>
+      <p:nvGrpSpPr>
+        <p:cNvPr id="1" name=""/>
+        <p:cNvGrpSpPr/>
+        <p:nvPr/>
+      </p:nvGrpSpPr>
+      <p:grpSpPr>
+        <a:xfrm>
+          <a:off x="0" y="0"/>
+          <a:ext cx="0" cy="0"/>
+          <a:chOff x="0" y="0"/>
+          <a:chExt cx="0" cy="0"/>
+        </a:xfrm>
+      </p:grpSpPr>
+      <p:sp>
+        <p:nvSpPr>
+          <p:cNvPr id="2" name="Slide Image Placeholder 1"/>
+          <p:cNvSpPr>
+            <a:spLocks noGrp="1"/>
+          </p:cNvSpPr>
+          <p:nvPr>
+            <p:ph type="sldImg" idx="2"/>
+          </p:nvPr>
+        </p:nvSpPr>
+        <p:spPr/>
+      </p:sp>
+      <p:sp>
+        <p:nvSpPr>
+          <p:cNvPr id="3" name="Notes Placeholder 2"/>
+          <p:cNvSpPr>
+            <a:spLocks noGrp="1"/>
+          </p:cNvSpPr>
+          <p:nvPr>
+            <p:ph type="body" idx="3" sz="quarter"/>
+          </p:nvPr>
+        </p:nvSpPr>
+        <p:spPr/>
+        <p:txBody>
+          <a:bodyPr/>
+          <a:lstStyle/>
+          <a:p>
+            <a:r>
+              <a:t>The adapter is not a full standalone base model. Prompt tokens are masked from training loss. The synthetic holdout uses a different seed but shares the generator. Publication of supplied dummy data was explicitly authorized by the user. Download the checkpoint-1 release; load the base revision plus adapter using the artifact README.</a:t>
+            </a:r>
+          </a:p>
         </p:txBody>
       </p:sp>
       <p:sp>
@@ -8170,19 +8241,308 @@
           </a:bodyPr>
           <a:lstStyle/>
           <a:p>
-            <a:pPr>
-              <a:spcAft>
-                <a:spcPts val="1200"/>
-              </a:spcAft>
-              <a:defRPr sz="1900" b="0">
-                <a:solidFill>
-                  <a:srgbClr val="596B82"/>
-                </a:solidFill>
-                <a:latin typeface="Aptos"/>
-              </a:defRPr>
-            </a:pPr>
-            <a:r>
-              <a:t>Cleaned personal metadata stays local; model prompts retain the typed feature allowlist.</a:t>
+            <a:r>
+              <a:t>Dummy data and cleaned results are now public; model prompts still use only typed features.</a:t>
+            </a:r>
+          </a:p>
+        </p:txBody>
+      </p:sp>
+    </p:spTree>
+  </p:cSld>
+  <p:clrMapOvr>
+    <a:masterClrMapping/>
+  </p:clrMapOvr>
+</p:sld>
+</file>
+
+<file path=ppt/slides/slide15.xml><?xml version="1.0" encoding="utf-8"?>
+<p:sld xmlns:a="http://schemas.openxmlformats.org/drawingml/2006/main" xmlns:p="http://schemas.openxmlformats.org/presentationml/2006/main" xmlns:r="http://schemas.openxmlformats.org/officeDocument/2006/relationships">
+  <p:cSld>
+    <p:spTree>
+      <p:nvGrpSpPr>
+        <p:cNvPr id="1" name=""/>
+        <p:cNvGrpSpPr/>
+        <p:nvPr/>
+      </p:nvGrpSpPr>
+      <p:grpSpPr/>
+      <p:sp>
+        <p:nvSpPr>
+          <p:cNvPr id="2" name="TextBox 1"/>
+          <p:cNvSpPr txBox="1"/>
+          <p:nvPr/>
+        </p:nvSpPr>
+        <p:spPr>
+          <a:xfrm>
+            <a:off x="548640" y="548640"/>
+            <a:ext cx="10972800" cy="914400"/>
+          </a:xfrm>
+          <a:prstGeom prst="rect">
+            <a:avLst/>
+          </a:prstGeom>
+          <a:noFill/>
+        </p:spPr>
+        <p:txBody>
+          <a:bodyPr wrap="square">
+            <a:spAutoFit/>
+          </a:bodyPr>
+          <a:lstStyle/>
+          <a:p>
+            <a:pPr>
+              <a:defRPr sz="3200"/>
+            </a:pPr>
+            <a:r>
+              <a:t>Fine-tuning checkpoint: inspect, download, reload</a:t>
+            </a:r>
+          </a:p>
+        </p:txBody>
+      </p:sp>
+      <p:sp>
+        <p:nvSpPr>
+          <p:cNvPr id="3" name="TextBox 2"/>
+          <p:cNvSpPr txBox="1"/>
+          <p:nvPr/>
+        </p:nvSpPr>
+        <p:spPr>
+          <a:xfrm>
+            <a:off x="640080" y="1645920"/>
+            <a:ext cx="10972800" cy="914400"/>
+          </a:xfrm>
+          <a:prstGeom prst="rect">
+            <a:avLst/>
+          </a:prstGeom>
+          <a:noFill/>
+        </p:spPr>
+        <p:txBody>
+          <a:bodyPr wrap="square">
+            <a:spAutoFit/>
+          </a:bodyPr>
+          <a:lstStyle/>
+          <a:p>
+            <a:pPr>
+              <a:defRPr sz="2400"/>
+            </a:pPr>
+            <a:r>
+              <a:t>Frozen Llama 3.2 1B (4-bit)  +  trained QLoRA adapter  →  tuned classifier</a:t>
+            </a:r>
+          </a:p>
+        </p:txBody>
+      </p:sp>
+      <p:sp>
+        <p:nvSpPr>
+          <p:cNvPr id="4" name="TextBox 3"/>
+          <p:cNvSpPr txBox="1"/>
+          <p:nvPr/>
+        </p:nvSpPr>
+        <p:spPr>
+          <a:xfrm>
+            <a:off x="640080" y="2743200"/>
+            <a:ext cx="3474720" cy="2560320"/>
+          </a:xfrm>
+          <a:prstGeom prst="rect">
+            <a:avLst/>
+          </a:prstGeom>
+          <a:noFill/>
+        </p:spPr>
+        <p:txBody>
+          <a:bodyPr wrap="square">
+            <a:spAutoFit/>
+          </a:bodyPr>
+          <a:lstStyle/>
+          <a:p>
+            <a:pPr>
+              <a:defRPr sz="2100"/>
+            </a:pPr>
+            <a:r>
+              <a:t>TRAINED</a:t>
+            </a:r>
+          </a:p>
+          <a:p>
+            <a:pPr>
+              <a:defRPr sz="2100"/>
+            </a:pPr>
+            <a:r>
+              <a:t>512 synthetic scenarios</a:t>
+            </a:r>
+          </a:p>
+          <a:p>
+            <a:pPr>
+              <a:defRPr sz="2100"/>
+            </a:pPr>
+            <a:r>
+              <a:t>120 steps; rank 8</a:t>
+            </a:r>
+          </a:p>
+          <a:p>
+            <a:pPr>
+              <a:defRPr sz="2100"/>
+            </a:pPr>
+            <a:r>
+              <a:t>851,968 trainable weights</a:t>
+            </a:r>
+          </a:p>
+          <a:p>
+            <a:pPr>
+              <a:defRPr sz="2100"/>
+            </a:pPr>
+            <a:r>
+              <a:t>16 layers: query/value adapters</a:t>
+            </a:r>
+          </a:p>
+        </p:txBody>
+      </p:sp>
+      <p:sp>
+        <p:nvSpPr>
+          <p:cNvPr id="5" name="TextBox 4"/>
+          <p:cNvSpPr txBox="1"/>
+          <p:nvPr/>
+        </p:nvSpPr>
+        <p:spPr>
+          <a:xfrm>
+            <a:off x="4389120" y="2743200"/>
+            <a:ext cx="3474720" cy="2560320"/>
+          </a:xfrm>
+          <a:prstGeom prst="rect">
+            <a:avLst/>
+          </a:prstGeom>
+          <a:noFill/>
+        </p:spPr>
+        <p:txBody>
+          <a:bodyPr wrap="square">
+            <a:spAutoFit/>
+          </a:bodyPr>
+          <a:lstStyle/>
+          <a:p>
+            <a:pPr>
+              <a:defRPr sz="2100"/>
+            </a:pPr>
+            <a:r>
+              <a:t>VERIFIED</a:t>
+            </a:r>
+          </a:p>
+          <a:p>
+            <a:pPr>
+              <a:defRPr sz="2100"/>
+            </a:pPr>
+            <a:r>
+              <a:t>Adapter saved and reloaded</a:t>
+            </a:r>
+          </a:p>
+          <a:p>
+            <a:pPr>
+              <a:defRPr sz="2100"/>
+            </a:pPr>
+            <a:r>
+              <a:t>1,000 schema-valid predictions</a:t>
+            </a:r>
+          </a:p>
+          <a:p>
+            <a:pPr>
+              <a:defRPr sz="2100"/>
+            </a:pPr>
+            <a:r>
+              <a:t>Synthetic holdout: 50% → 75%</a:t>
+            </a:r>
+          </a:p>
+          <a:p>
+            <a:pPr>
+              <a:defRPr sz="2100"/>
+            </a:pPr>
+            <a:r>
+              <a:t>Real-world accuracy unknown</a:t>
+            </a:r>
+          </a:p>
+        </p:txBody>
+      </p:sp>
+      <p:sp>
+        <p:nvSpPr>
+          <p:cNvPr id="6" name="TextBox 5"/>
+          <p:cNvSpPr txBox="1"/>
+          <p:nvPr/>
+        </p:nvSpPr>
+        <p:spPr>
+          <a:xfrm>
+            <a:off x="8138160" y="2743200"/>
+            <a:ext cx="3474720" cy="2560320"/>
+          </a:xfrm>
+          <a:prstGeom prst="rect">
+            <a:avLst/>
+          </a:prstGeom>
+          <a:noFill/>
+        </p:spPr>
+        <p:txBody>
+          <a:bodyPr wrap="square">
+            <a:spAutoFit/>
+          </a:bodyPr>
+          <a:lstStyle/>
+          <a:p>
+            <a:pPr>
+              <a:defRPr sz="2100"/>
+            </a:pPr>
+            <a:r>
+              <a:t>PUBLISHED</a:t>
+            </a:r>
+          </a:p>
+          <a:p>
+            <a:pPr>
+              <a:defRPr sz="2100"/>
+            </a:pPr>
+            <a:r>
+              <a:t>Adapter + config + hashes</a:t>
+            </a:r>
+          </a:p>
+          <a:p>
+            <a:pPr>
+              <a:defRPr sz="2100"/>
+            </a:pPr>
+            <a:r>
+              <a:t>Dummy input CSVs</a:t>
+            </a:r>
+          </a:p>
+          <a:p>
+            <a:pPr>
+              <a:defRPr sz="2100"/>
+            </a:pPr>
+            <a:r>
+              <a:t>Predictions + cleaning reports</a:t>
+            </a:r>
+          </a:p>
+          <a:p>
+            <a:pPr>
+              <a:defRPr sz="2100"/>
+            </a:pPr>
+            <a:r>
+              <a:t>GitHub checkpoint ZIP</a:t>
+            </a:r>
+          </a:p>
+        </p:txBody>
+      </p:sp>
+      <p:sp>
+        <p:nvSpPr>
+          <p:cNvPr id="7" name="TextBox 6"/>
+          <p:cNvSpPr txBox="1"/>
+          <p:nvPr/>
+        </p:nvSpPr>
+        <p:spPr>
+          <a:xfrm>
+            <a:off x="640080" y="5760720"/>
+            <a:ext cx="10972800" cy="640080"/>
+          </a:xfrm>
+          <a:prstGeom prst="rect">
+            <a:avLst/>
+          </a:prstGeom>
+          <a:noFill/>
+        </p:spPr>
+        <p:txBody>
+          <a:bodyPr wrap="square">
+            <a:spAutoFit/>
+          </a:bodyPr>
+          <a:lstStyle/>
+          <a:p>
+            <a:pPr>
+              <a:defRPr sz="1800"/>
+            </a:pPr>
+            <a:r>
+              <a:t>Built with Llama. Reloading requires the pinned base model and Apple MLX; viewing results does not.</a:t>
             </a:r>
           </a:p>
         </p:txBody>

</xml_diff>

<commit_message>
Add verified offline data-quality dashboard
</commit_message>
<xml_diff>
--- a/docs/presentation.pptx
+++ b/docs/presentation.pptx
@@ -20,6 +20,7 @@
     <p:sldId id="268" r:id="rId20"/>
     <p:sldId id="269" r:id="rId21"/>
     <p:sldId id="270" r:id="rId22"/>
+    <p:sldId id="271" r:id="rId23"/>
   </p:sldIdLst>
   <p:sldSz cx="12191695" cy="6858000" type="screen4x3"/>
   <p:notesSz cx="6858000" cy="9144000"/>
@@ -8543,6 +8544,172 @@
             </a:pPr>
             <a:r>
               <a:t>Built with Llama. Reloading requires the pinned base model and Apple MLX; viewing results does not.</a:t>
+            </a:r>
+          </a:p>
+        </p:txBody>
+      </p:sp>
+    </p:spTree>
+  </p:cSld>
+  <p:clrMapOvr>
+    <a:masterClrMapping/>
+  </p:clrMapOvr>
+</p:sld>
+</file>
+
+<file path=ppt/slides/slide16.xml><?xml version="1.0" encoding="utf-8"?>
+<p:sld xmlns:a="http://schemas.openxmlformats.org/drawingml/2006/main" xmlns:p="http://schemas.openxmlformats.org/presentationml/2006/main" xmlns:r="http://schemas.openxmlformats.org/officeDocument/2006/relationships">
+  <p:cSld>
+    <p:spTree>
+      <p:nvGrpSpPr>
+        <p:cNvPr id="1" name=""/>
+        <p:cNvGrpSpPr/>
+        <p:nvPr/>
+      </p:nvGrpSpPr>
+      <p:grpSpPr/>
+      <p:sp>
+        <p:nvSpPr>
+          <p:cNvPr id="2" name="TextBox 1"/>
+          <p:cNvSpPr txBox="1"/>
+          <p:nvPr/>
+        </p:nvSpPr>
+        <p:spPr>
+          <a:xfrm>
+            <a:off x="548640" y="548640"/>
+            <a:ext cx="10972800" cy="1188720"/>
+          </a:xfrm>
+          <a:prstGeom prst="rect">
+            <a:avLst/>
+          </a:prstGeom>
+          <a:noFill/>
+        </p:spPr>
+        <p:txBody>
+          <a:bodyPr wrap="square">
+            <a:spAutoFit/>
+          </a:bodyPr>
+          <a:lstStyle/>
+          <a:p>
+            <a:pPr>
+              <a:defRPr sz="3000"/>
+            </a:pPr>
+            <a:r>
+              <a:t>Data quality: a dashboard without GPU dependencies</a:t>
+            </a:r>
+          </a:p>
+        </p:txBody>
+      </p:sp>
+      <p:sp>
+        <p:nvSpPr>
+          <p:cNvPr id="3" name="TextBox 2"/>
+          <p:cNvSpPr txBox="1"/>
+          <p:nvPr/>
+        </p:nvSpPr>
+        <p:spPr>
+          <a:xfrm>
+            <a:off x="640080" y="1920240"/>
+            <a:ext cx="10972800" cy="914400"/>
+          </a:xfrm>
+          <a:prstGeom prst="rect">
+            <a:avLst/>
+          </a:prstGeom>
+          <a:noFill/>
+        </p:spPr>
+        <p:txBody>
+          <a:bodyPr wrap="square">
+            <a:spAutoFit/>
+          </a:bodyPr>
+          <a:lstStyle/>
+          <a:p>
+            <a:pPr>
+              <a:defRPr sz="2400"/>
+            </a:pPr>
+            <a:r>
+              <a:t>1,000 source rows → 988 unique transactions → visible quality issues</a:t>
+            </a:r>
+          </a:p>
+        </p:txBody>
+      </p:sp>
+      <p:sp>
+        <p:nvSpPr>
+          <p:cNvPr id="4" name="TextBox 3"/>
+          <p:cNvSpPr txBox="1"/>
+          <p:nvPr/>
+        </p:nvSpPr>
+        <p:spPr>
+          <a:xfrm>
+            <a:off x="640080" y="2926080"/>
+            <a:ext cx="10789920" cy="2286000"/>
+          </a:xfrm>
+          <a:prstGeom prst="rect">
+            <a:avLst/>
+          </a:prstGeom>
+          <a:noFill/>
+        </p:spPr>
+        <p:txBody>
+          <a:bodyPr wrap="square">
+            <a:spAutoFit/>
+          </a:bodyPr>
+          <a:lstStyle/>
+          <a:p>
+            <a:pPr>
+              <a:defRPr sz="2300"/>
+            </a:pPr>
+            <a:r>
+              <a:t>Filter by table or field</a:t>
+            </a:r>
+          </a:p>
+          <a:p>
+            <a:pPr>
+              <a:defRPr sz="2300"/>
+            </a:pPr>
+            <a:r>
+              <a:t>Inspect missing features and broken references</a:t>
+            </a:r>
+          </a:p>
+          <a:p>
+            <a:pPr>
+              <a:defRPr sz="2300"/>
+            </a:pPr>
+            <a:r>
+              <a:t>Compare counts with explicit denominators</a:t>
+            </a:r>
+          </a:p>
+          <a:p>
+            <a:pPr>
+              <a:defRPr sz="2300"/>
+            </a:pPr>
+            <a:r>
+              <a:t>Optional missing metadata is not fraud</a:t>
+            </a:r>
+          </a:p>
+        </p:txBody>
+      </p:sp>
+      <p:sp>
+        <p:nvSpPr>
+          <p:cNvPr id="5" name="TextBox 4"/>
+          <p:cNvSpPr txBox="1"/>
+          <p:nvPr/>
+        </p:nvSpPr>
+        <p:spPr>
+          <a:xfrm>
+            <a:off x="640080" y="5669280"/>
+            <a:ext cx="10789920" cy="731520"/>
+          </a:xfrm>
+          <a:prstGeom prst="rect">
+            <a:avLst/>
+          </a:prstGeom>
+          <a:noFill/>
+        </p:spPr>
+        <p:txBody>
+          <a:bodyPr wrap="square">
+            <a:spAutoFit/>
+          </a:bodyPr>
+          <a:lstStyle/>
+          <a:p>
+            <a:pPr>
+              <a:defRPr sz="1800"/>
+            </a:pPr>
+            <a:r>
+              <a:t>Self-contained HTML; open offline in a browser. Builder verifies snapshot hashes. Tested in Chrome.</a:t>
             </a:r>
           </a:p>
         </p:txBody>

</xml_diff>

<commit_message>
Add tested offline analyst dashboard and browser access
</commit_message>
<xml_diff>
--- a/docs/presentation.pptx
+++ b/docs/presentation.pptx
@@ -21,6 +21,7 @@
     <p:sldId id="269" r:id="rId21"/>
     <p:sldId id="270" r:id="rId22"/>
     <p:sldId id="271" r:id="rId23"/>
+    <p:sldId id="272" r:id="rId24"/>
   </p:sldIdLst>
   <p:sldSz cx="12191695" cy="6858000" type="screen4x3"/>
   <p:notesSz cx="6858000" cy="9144000"/>
@@ -8710,6 +8711,172 @@
             </a:pPr>
             <a:r>
               <a:t>Self-contained HTML; open offline in a browser. Builder verifies snapshot hashes. Tested in Chrome.</a:t>
+            </a:r>
+          </a:p>
+        </p:txBody>
+      </p:sp>
+    </p:spTree>
+  </p:cSld>
+  <p:clrMapOvr>
+    <a:masterClrMapping/>
+  </p:clrMapOvr>
+</p:sld>
+</file>
+
+<file path=ppt/slides/slide17.xml><?xml version="1.0" encoding="utf-8"?>
+<p:sld xmlns:a="http://schemas.openxmlformats.org/drawingml/2006/main" xmlns:p="http://schemas.openxmlformats.org/presentationml/2006/main" xmlns:r="http://schemas.openxmlformats.org/officeDocument/2006/relationships">
+  <p:cSld>
+    <p:spTree>
+      <p:nvGrpSpPr>
+        <p:cNvPr id="1" name=""/>
+        <p:cNvGrpSpPr/>
+        <p:nvPr/>
+      </p:nvGrpSpPr>
+      <p:grpSpPr/>
+      <p:sp>
+        <p:nvSpPr>
+          <p:cNvPr id="2" name="TextBox 1"/>
+          <p:cNvSpPr txBox="1"/>
+          <p:nvPr/>
+        </p:nvSpPr>
+        <p:spPr>
+          <a:xfrm>
+            <a:off x="548640" y="548640"/>
+            <a:ext cx="10972800" cy="1188720"/>
+          </a:xfrm>
+          <a:prstGeom prst="rect">
+            <a:avLst/>
+          </a:prstGeom>
+          <a:noFill/>
+        </p:spPr>
+        <p:txBody>
+          <a:bodyPr wrap="square">
+            <a:spAutoFit/>
+          </a:bodyPr>
+          <a:lstStyle/>
+          <a:p>
+            <a:pPr>
+              <a:defRPr sz="3000"/>
+            </a:pPr>
+            <a:r>
+              <a:t>Analyst dashboard: from recorded results to review</a:t>
+            </a:r>
+          </a:p>
+        </p:txBody>
+      </p:sp>
+      <p:sp>
+        <p:nvSpPr>
+          <p:cNvPr id="3" name="TextBox 2"/>
+          <p:cNvSpPr txBox="1"/>
+          <p:nvPr/>
+        </p:nvSpPr>
+        <p:spPr>
+          <a:xfrm>
+            <a:off x="640080" y="1920240"/>
+            <a:ext cx="10972800" cy="914400"/>
+          </a:xfrm>
+          <a:prstGeom prst="rect">
+            <a:avLst/>
+          </a:prstGeom>
+          <a:noFill/>
+        </p:spPr>
+        <p:txBody>
+          <a:bodyPr wrap="square">
+            <a:spAutoFit/>
+          </a:bodyPr>
+          <a:lstStyle/>
+          <a:p>
+            <a:pPr>
+              <a:defRPr sz="2400"/>
+            </a:pPr>
+            <a:r>
+              <a:t>Overview → category heatmap → review queue → prompt-boundary demonstration</a:t>
+            </a:r>
+          </a:p>
+        </p:txBody>
+      </p:sp>
+      <p:sp>
+        <p:nvSpPr>
+          <p:cNvPr id="4" name="TextBox 3"/>
+          <p:cNvSpPr txBox="1"/>
+          <p:nvPr/>
+        </p:nvSpPr>
+        <p:spPr>
+          <a:xfrm>
+            <a:off x="640080" y="2926080"/>
+            <a:ext cx="10789920" cy="2286000"/>
+          </a:xfrm>
+          <a:prstGeom prst="rect">
+            <a:avLst/>
+          </a:prstGeom>
+          <a:noFill/>
+        </p:spPr>
+        <p:txBody>
+          <a:bodyPr wrap="square">
+            <a:spAutoFit/>
+          </a:bodyPr>
+          <a:lstStyle/>
+          <a:p>
+            <a:pPr>
+              <a:defRPr sz="2300"/>
+            </a:pPr>
+            <a:r>
+              <a:t>Recorded predictions, not live inference</a:t>
+            </a:r>
+          </a:p>
+          <a:p>
+            <a:pPr>
+              <a:defRPr sz="2300"/>
+            </a:pPr>
+            <a:r>
+              <a:t>Unique-transaction rates and low-sample warnings</a:t>
+            </a:r>
+          </a:p>
+          <a:p>
+            <a:pPr>
+              <a:defRPr sz="2300"/>
+            </a:pPr>
+            <a:r>
+              <a:t>Amounts separated by currency; no conversion assumptions</a:t>
+            </a:r>
+          </a:p>
+          <a:p>
+            <a:pPr>
+              <a:defRPr sz="2300"/>
+            </a:pPr>
+            <a:r>
+              <a:t>Injected notes remain outside the fixed typed prompt</a:t>
+            </a:r>
+          </a:p>
+        </p:txBody>
+      </p:sp>
+      <p:sp>
+        <p:nvSpPr>
+          <p:cNvPr id="5" name="TextBox 4"/>
+          <p:cNvSpPr txBox="1"/>
+          <p:nvPr/>
+        </p:nvSpPr>
+        <p:spPr>
+          <a:xfrm>
+            <a:off x="640080" y="5669280"/>
+            <a:ext cx="10789920" cy="731520"/>
+          </a:xfrm>
+          <a:prstGeom prst="rect">
+            <a:avLst/>
+          </a:prstGeom>
+          <a:noFill/>
+        </p:spPr>
+        <p:txBody>
+          <a:bodyPr wrap="square">
+            <a:spAutoFit/>
+          </a:bodyPr>
+          <a:lstStyle/>
+          <a:p>
+            <a:pPr>
+              <a:defRPr sz="1800"/>
+            </a:pPr>
+            <a:r>
+              <a:t>A model flag is a review signal, not confirmed fraud. No automatic customer blocking.</a:t>
             </a:r>
           </a:p>
         </p:txBody>

</xml_diff>

<commit_message>
Add local analyst feedback and actual-data injection demonstration
</commit_message>
<xml_diff>
--- a/docs/presentation.pptx
+++ b/docs/presentation.pptx
@@ -22,6 +22,8 @@
     <p:sldId id="270" r:id="rId22"/>
     <p:sldId id="271" r:id="rId23"/>
     <p:sldId id="272" r:id="rId24"/>
+    <p:sldId id="273" r:id="rId25"/>
+    <p:sldId id="274" r:id="rId26"/>
   </p:sldIdLst>
   <p:sldSz cx="12191695" cy="6858000" type="screen4x3"/>
   <p:notesSz cx="6858000" cy="9144000"/>
@@ -919,6 +921,146 @@
           <a:p>
             <a:r>
               <a:t>The adapter is not a full standalone base model. Prompt tokens are masked from training loss. The synthetic holdout uses a different seed but shares the generator. Publication of supplied dummy data was explicitly authorized by the user. Download the checkpoint-1 release; load the base revision plus adapter using the artifact README.</a:t>
+            </a:r>
+          </a:p>
+        </p:txBody>
+      </p:sp>
+      <p:sp>
+        <p:nvSpPr>
+          <p:cNvPr id="4" name="Slide Number Placeholder 3"/>
+          <p:cNvSpPr>
+            <a:spLocks noGrp="1"/>
+          </p:cNvSpPr>
+          <p:nvPr>
+            <p:ph type="sldNum" idx="5" sz="quarter"/>
+          </p:nvPr>
+        </p:nvSpPr>
+        <p:spPr/>
+      </p:sp>
+    </p:spTree>
+  </p:cSld>
+  <p:clrMapOvr>
+    <a:masterClrMapping/>
+  </p:clrMapOvr>
+</p:notes>
+</file>
+
+<file path=ppt/notesSlides/notesSlide16.xml><?xml version="1.0" encoding="utf-8"?>
+<p:notes xmlns:a="http://schemas.openxmlformats.org/drawingml/2006/main" xmlns:p="http://schemas.openxmlformats.org/presentationml/2006/main" xmlns:r="http://schemas.openxmlformats.org/officeDocument/2006/relationships">
+  <p:cSld>
+    <p:spTree>
+      <p:nvGrpSpPr>
+        <p:cNvPr id="1" name=""/>
+        <p:cNvGrpSpPr/>
+        <p:nvPr/>
+      </p:nvGrpSpPr>
+      <p:grpSpPr>
+        <a:xfrm>
+          <a:off x="0" y="0"/>
+          <a:ext cx="0" cy="0"/>
+          <a:chOff x="0" y="0"/>
+          <a:chExt cx="0" cy="0"/>
+        </a:xfrm>
+      </p:grpSpPr>
+      <p:sp>
+        <p:nvSpPr>
+          <p:cNvPr id="2" name="Slide Image Placeholder 1"/>
+          <p:cNvSpPr>
+            <a:spLocks noGrp="1"/>
+          </p:cNvSpPr>
+          <p:nvPr>
+            <p:ph type="sldImg" idx="2"/>
+          </p:nvPr>
+        </p:nvSpPr>
+        <p:spPr/>
+      </p:sp>
+      <p:sp>
+        <p:nvSpPr>
+          <p:cNvPr id="3" name="Notes Placeholder 2"/>
+          <p:cNvSpPr>
+            <a:spLocks noGrp="1"/>
+          </p:cNvSpPr>
+          <p:nvPr>
+            <p:ph type="body" idx="3" sz="quarter"/>
+          </p:nvPr>
+        </p:nvSpPr>
+        <p:spPr/>
+        <p:txBody>
+          <a:bodyPr/>
+          <a:lstStyle/>
+          <a:p>
+            <a:r>
+              <a:t>Local browser prototype—not authenticated or tamper-proof. All feedback remains unverified; no automatic training labels.</a:t>
+            </a:r>
+          </a:p>
+        </p:txBody>
+      </p:sp>
+      <p:sp>
+        <p:nvSpPr>
+          <p:cNvPr id="4" name="Slide Number Placeholder 3"/>
+          <p:cNvSpPr>
+            <a:spLocks noGrp="1"/>
+          </p:cNvSpPr>
+          <p:nvPr>
+            <p:ph type="sldNum" idx="5" sz="quarter"/>
+          </p:nvPr>
+        </p:nvSpPr>
+        <p:spPr/>
+      </p:sp>
+    </p:spTree>
+  </p:cSld>
+  <p:clrMapOvr>
+    <a:masterClrMapping/>
+  </p:clrMapOvr>
+</p:notes>
+</file>
+
+<file path=ppt/notesSlides/notesSlide17.xml><?xml version="1.0" encoding="utf-8"?>
+<p:notes xmlns:a="http://schemas.openxmlformats.org/drawingml/2006/main" xmlns:p="http://schemas.openxmlformats.org/presentationml/2006/main" xmlns:r="http://schemas.openxmlformats.org/officeDocument/2006/relationships">
+  <p:cSld>
+    <p:spTree>
+      <p:nvGrpSpPr>
+        <p:cNvPr id="1" name=""/>
+        <p:cNvGrpSpPr/>
+        <p:nvPr/>
+      </p:nvGrpSpPr>
+      <p:grpSpPr>
+        <a:xfrm>
+          <a:off x="0" y="0"/>
+          <a:ext cx="0" cy="0"/>
+          <a:chOff x="0" y="0"/>
+          <a:chExt cx="0" cy="0"/>
+        </a:xfrm>
+      </p:grpSpPr>
+      <p:sp>
+        <p:nvSpPr>
+          <p:cNvPr id="2" name="Slide Image Placeholder 1"/>
+          <p:cNvSpPr>
+            <a:spLocks noGrp="1"/>
+          </p:cNvSpPr>
+          <p:nvPr>
+            <p:ph type="sldImg" idx="2"/>
+          </p:nvPr>
+        </p:nvSpPr>
+        <p:spPr/>
+      </p:sp>
+      <p:sp>
+        <p:nvSpPr>
+          <p:cNvPr id="3" name="Notes Placeholder 2"/>
+          <p:cNvSpPr>
+            <a:spLocks noGrp="1"/>
+          </p:cNvSpPr>
+          <p:nvPr>
+            <p:ph type="body" idx="3" sz="quarter"/>
+          </p:nvPr>
+        </p:nvSpPr>
+        <p:spPr/>
+        <p:txBody>
+          <a:bodyPr/>
+          <a:lstStyle/>
+          <a:p>
+            <a:r>
+              <a:t>Text exclusion is structural. Falsified numeric data can still affect predictions; this is not universal attack immunity.</a:t>
             </a:r>
           </a:p>
         </p:txBody>
@@ -8877,6 +9019,338 @@
             </a:pPr>
             <a:r>
               <a:t>A model flag is a review signal, not confirmed fraud. No automatic customer blocking.</a:t>
+            </a:r>
+          </a:p>
+        </p:txBody>
+      </p:sp>
+    </p:spTree>
+  </p:cSld>
+  <p:clrMapOvr>
+    <a:masterClrMapping/>
+  </p:clrMapOvr>
+</p:sld>
+</file>
+
+<file path=ppt/slides/slide18.xml><?xml version="1.0" encoding="utf-8"?>
+<p:sld xmlns:a="http://schemas.openxmlformats.org/drawingml/2006/main" xmlns:p="http://schemas.openxmlformats.org/presentationml/2006/main" xmlns:r="http://schemas.openxmlformats.org/officeDocument/2006/relationships">
+  <p:cSld>
+    <p:spTree>
+      <p:nvGrpSpPr>
+        <p:cNvPr id="1" name=""/>
+        <p:cNvGrpSpPr/>
+        <p:nvPr/>
+      </p:nvGrpSpPr>
+      <p:grpSpPr/>
+      <p:sp>
+        <p:nvSpPr>
+          <p:cNvPr id="2" name="TextBox 1"/>
+          <p:cNvSpPr txBox="1"/>
+          <p:nvPr/>
+        </p:nvSpPr>
+        <p:spPr>
+          <a:xfrm>
+            <a:off x="548640" y="548640"/>
+            <a:ext cx="10972800" cy="1188720"/>
+          </a:xfrm>
+          <a:prstGeom prst="rect">
+            <a:avLst/>
+          </a:prstGeom>
+          <a:noFill/>
+        </p:spPr>
+        <p:txBody>
+          <a:bodyPr wrap="square">
+            <a:spAutoFit/>
+          </a:bodyPr>
+          <a:lstStyle/>
+          <a:p>
+            <a:pPr>
+              <a:defRPr sz="3000"/>
+            </a:pPr>
+            <a:r>
+              <a:t>Feedback capture: opinions stay separate from predictions</a:t>
+            </a:r>
+          </a:p>
+        </p:txBody>
+      </p:sp>
+      <p:sp>
+        <p:nvSpPr>
+          <p:cNvPr id="3" name="TextBox 2"/>
+          <p:cNvSpPr txBox="1"/>
+          <p:nvPr/>
+        </p:nvSpPr>
+        <p:spPr>
+          <a:xfrm>
+            <a:off x="640080" y="1920240"/>
+            <a:ext cx="10972800" cy="914400"/>
+          </a:xfrm>
+          <a:prstGeom prst="rect">
+            <a:avLst/>
+          </a:prstGeom>
+          <a:noFill/>
+        </p:spPr>
+        <p:txBody>
+          <a:bodyPr wrap="square">
+            <a:spAutoFit/>
+          </a:bodyPr>
+          <a:lstStyle/>
+          <a:p>
+            <a:pPr>
+              <a:defRPr sz="2300"/>
+            </a:pPr>
+            <a:r>
+              <a:t>Inspect evidence → record assessment → save local history → export backup</a:t>
+            </a:r>
+          </a:p>
+        </p:txBody>
+      </p:sp>
+      <p:sp>
+        <p:nvSpPr>
+          <p:cNvPr id="4" name="TextBox 3"/>
+          <p:cNvSpPr txBox="1"/>
+          <p:nvPr/>
+        </p:nvSpPr>
+        <p:spPr>
+          <a:xfrm>
+            <a:off x="640080" y="2926080"/>
+            <a:ext cx="10789920" cy="2286000"/>
+          </a:xfrm>
+          <a:prstGeom prst="rect">
+            <a:avLst/>
+          </a:prstGeom>
+          <a:noFill/>
+        </p:spPr>
+        <p:txBody>
+          <a:bodyPr wrap="square">
+            <a:spAutoFit/>
+          </a:bodyPr>
+          <a:lstStyle/>
+          <a:p>
+            <a:pPr>
+              <a:defRPr sz="2300"/>
+            </a:pPr>
+            <a:r>
+              <a:t>Reviewer alias + UTC timestamp + reason</a:t>
+            </a:r>
+          </a:p>
+          <a:p>
+            <a:pPr>
+              <a:defRPr sz="2300"/>
+            </a:pPr>
+            <a:r>
+              <a:t>Prediction/data/adapter hashes preserve context</a:t>
+            </a:r>
+          </a:p>
+          <a:p>
+            <a:pPr>
+              <a:defRPr sz="2300"/>
+            </a:pPr>
+            <a:r>
+              <a:t>JSON import validates IDs and deduplicates events</a:t>
+            </a:r>
+          </a:p>
+          <a:p>
+            <a:pPr>
+              <a:defRPr sz="2300"/>
+            </a:pPr>
+            <a:r>
+              <a:t>Original model predictions remain unchanged</a:t>
+            </a:r>
+          </a:p>
+        </p:txBody>
+      </p:sp>
+      <p:sp>
+        <p:nvSpPr>
+          <p:cNvPr id="5" name="TextBox 4"/>
+          <p:cNvSpPr txBox="1"/>
+          <p:nvPr/>
+        </p:nvSpPr>
+        <p:spPr>
+          <a:xfrm>
+            <a:off x="640080" y="5577840"/>
+            <a:ext cx="10789920" cy="868680"/>
+          </a:xfrm>
+          <a:prstGeom prst="rect">
+            <a:avLst/>
+          </a:prstGeom>
+          <a:noFill/>
+        </p:spPr>
+        <p:txBody>
+          <a:bodyPr wrap="square">
+            <a:spAutoFit/>
+          </a:bodyPr>
+          <a:lstStyle/>
+          <a:p>
+            <a:pPr>
+              <a:defRPr sz="1800"/>
+            </a:pPr>
+            <a:r>
+              <a:t>Local browser prototype—not authenticated or tamper-proof. All feedback remains unverified; no automatic training labels.</a:t>
+            </a:r>
+          </a:p>
+        </p:txBody>
+      </p:sp>
+    </p:spTree>
+  </p:cSld>
+  <p:clrMapOvr>
+    <a:masterClrMapping/>
+  </p:clrMapOvr>
+</p:sld>
+</file>
+
+<file path=ppt/slides/slide19.xml><?xml version="1.0" encoding="utf-8"?>
+<p:sld xmlns:a="http://schemas.openxmlformats.org/drawingml/2006/main" xmlns:p="http://schemas.openxmlformats.org/presentationml/2006/main" xmlns:r="http://schemas.openxmlformats.org/officeDocument/2006/relationships">
+  <p:cSld>
+    <p:spTree>
+      <p:nvGrpSpPr>
+        <p:cNvPr id="1" name=""/>
+        <p:cNvGrpSpPr/>
+        <p:nvPr/>
+      </p:nvGrpSpPr>
+      <p:grpSpPr/>
+      <p:sp>
+        <p:nvSpPr>
+          <p:cNvPr id="2" name="TextBox 1"/>
+          <p:cNvSpPr txBox="1"/>
+          <p:nvPr/>
+        </p:nvSpPr>
+        <p:spPr>
+          <a:xfrm>
+            <a:off x="548640" y="548640"/>
+            <a:ext cx="10972800" cy="1188720"/>
+          </a:xfrm>
+          <a:prstGeom prst="rect">
+            <a:avLst/>
+          </a:prstGeom>
+          <a:noFill/>
+        </p:spPr>
+        <p:txBody>
+          <a:bodyPr wrap="square">
+            <a:spAutoFit/>
+          </a:bodyPr>
+          <a:lstStyle/>
+          <a:p>
+            <a:pPr>
+              <a:defRPr sz="3000"/>
+            </a:pPr>
+            <a:r>
+              <a:t>Injection demonstration on the actual transaction data</a:t>
+            </a:r>
+          </a:p>
+        </p:txBody>
+      </p:sp>
+      <p:sp>
+        <p:nvSpPr>
+          <p:cNvPr id="3" name="TextBox 2"/>
+          <p:cNvSpPr txBox="1"/>
+          <p:nvPr/>
+        </p:nvSpPr>
+        <p:spPr>
+          <a:xfrm>
+            <a:off x="640080" y="1920240"/>
+            <a:ext cx="10972800" cy="914400"/>
+          </a:xfrm>
+          <a:prstGeom prst="rect">
+            <a:avLst/>
+          </a:prstGeom>
+          <a:noFill/>
+        </p:spPr>
+        <p:txBody>
+          <a:bodyPr wrap="square">
+            <a:spAutoFit/>
+          </a:bodyPr>
+          <a:lstStyle/>
+          <a:p>
+            <a:pPr>
+              <a:defRPr sz="2300"/>
+            </a:pPr>
+            <a:r>
+              <a:t>Select one of 988 cases → type a hostile note → inspect the unchanged prompt</a:t>
+            </a:r>
+          </a:p>
+        </p:txBody>
+      </p:sp>
+      <p:sp>
+        <p:nvSpPr>
+          <p:cNvPr id="4" name="TextBox 3"/>
+          <p:cNvSpPr txBox="1"/>
+          <p:nvPr/>
+        </p:nvSpPr>
+        <p:spPr>
+          <a:xfrm>
+            <a:off x="640080" y="2926080"/>
+            <a:ext cx="10789920" cy="2286000"/>
+          </a:xfrm>
+          <a:prstGeom prst="rect">
+            <a:avLst/>
+          </a:prstGeom>
+          <a:noFill/>
+        </p:spPr>
+        <p:txBody>
+          <a:bodyPr wrap="square">
+            <a:spAutoFit/>
+          </a:bodyPr>
+          <a:lstStyle/>
+          <a:p>
+            <a:pPr>
+              <a:defRPr sz="2300"/>
+            </a:pPr>
+            <a:r>
+              <a:t>Prompts generated by the real Python pipeline</a:t>
+            </a:r>
+          </a:p>
+          <a:p>
+            <a:pPr>
+              <a:defRPr sz="2300"/>
+            </a:pPr>
+            <a:r>
+              <a:t>Three attacks tested across all 988 unique cases</a:t>
+            </a:r>
+          </a:p>
+          <a:p>
+            <a:pPr>
+              <a:defRPr sz="2300"/>
+            </a:pPr>
+            <a:r>
+              <a:t>2,964 poisoned-input comparisons pass</a:t>
+            </a:r>
+          </a:p>
+          <a:p>
+            <a:pPr>
+              <a:defRPr sz="2300"/>
+            </a:pPr>
+            <a:r>
+              <a:t>Browser displays evidence; it does not rerun inference</a:t>
+            </a:r>
+          </a:p>
+        </p:txBody>
+      </p:sp>
+      <p:sp>
+        <p:nvSpPr>
+          <p:cNvPr id="5" name="TextBox 4"/>
+          <p:cNvSpPr txBox="1"/>
+          <p:nvPr/>
+        </p:nvSpPr>
+        <p:spPr>
+          <a:xfrm>
+            <a:off x="640080" y="5577840"/>
+            <a:ext cx="10789920" cy="868680"/>
+          </a:xfrm>
+          <a:prstGeom prst="rect">
+            <a:avLst/>
+          </a:prstGeom>
+          <a:noFill/>
+        </p:spPr>
+        <p:txBody>
+          <a:bodyPr wrap="square">
+            <a:spAutoFit/>
+          </a:bodyPr>
+          <a:lstStyle/>
+          <a:p>
+            <a:pPr>
+              <a:defRPr sz="1800"/>
+            </a:pPr>
+            <a:r>
+              <a:t>Text exclusion is structural. Falsified numeric data can still affect predictions; this is not universal attack immunity.</a:t>
             </a:r>
           </a:p>
         </p:txBody>

</xml_diff>